<commit_message>
fix(diagram): eliminate line occlusions in cloud architecture trust boundaries and update video deliverables
- Redesign Slide 6 architecture diagram with clean vertical channels and zero line crossings
- Explicitly delineate CLIENT and GOOGLE CLOUD SECURE PERIMETER trust boundaries
- Highlight dual-mode Vertex AI Agent Platform and Gemini Developer API support
- Update proposal PDF, PPTX, and slide generation scripts
- Re-render Part 1 slides (part1_slides.mp4) with updated narration and title-safe subtitles
- Re-assemble official combined demo (OpsCrew_Combined_Official_Demo_165s.mp4, 142.04s)
- Formally deploy dual-mode adaptive revision opscrew-00005-g99 to Cloud Run production
</commit_message>
<xml_diff>
--- a/submission/OpsCrew_Proposal_Cloud_cloud-public-links-review-2026-10-14.pptx
+++ b/submission/OpsCrew_Proposal_Cloud_cloud-public-links-review-2026-10-14.pptx
@@ -13771,1074 +13771,6 @@
       <p:grpSpPr>
         <a:xfrm xmlns:a="http://schemas.openxmlformats.org/drawingml/2006/main"/>
       </p:grpSpPr>
-      <p:cxnSp>
-        <p:nvCxnSpPr>
-          <p:cNvPr id="124" name="">
-            <a:extLst xmlns:a="http://schemas.openxmlformats.org/drawingml/2006/main">
-              <a:ext uri="{FF2B5EF4-FFF2-40B4-BE49-F238E27FC236}">
-                <a16:creationId xmlns:a16="http://schemas.microsoft.com/office/drawing/2014/main" id="{9F0DBB9C-B7F2-4E64-A4B0-13C3F21B138F}"/>
-              </a:ext>
-            </a:extLst>
-          </p:cNvPr>
-          <p:cNvCxnSpPr>
-            <a:stCxn xmlns:a="http://schemas.openxmlformats.org/drawingml/2006/main" id="120" idx="1"/>
-            <a:endCxn xmlns:a="http://schemas.openxmlformats.org/drawingml/2006/main" id="114" idx="3"/>
-          </p:cNvCxnSpPr>
-          <p:nvPr/>
-        </p:nvCxnSpPr>
-        <p:spPr>
-          <a:xfrm xmlns:a="http://schemas.openxmlformats.org/drawingml/2006/main" flipH="1" flipV="1">
-            <a:off x="5819775" y="1762125"/>
-            <a:ext cx="428625" cy="1514475"/>
-          </a:xfrm>
-          <a:prstGeom xmlns:a="http://schemas.openxmlformats.org/drawingml/2006/main" prst="bentConnector3">
-            <a:avLst>
-              <a:gd name="adj1" fmla="val 50000"/>
-            </a:avLst>
-          </a:prstGeom>
-          <a:ln xmlns:a="http://schemas.openxmlformats.org/drawingml/2006/main" w="19050">
-            <a:solidFill>
-              <a:srgbClr val="567481"/>
-            </a:solidFill>
-            <a:prstDash val="solid"/>
-            <a:tailEnd type="triangle" w="med" len="med"/>
-          </a:ln>
-        </p:spPr>
-      </p:cxnSp>
-      <p:cxnSp>
-        <p:nvCxnSpPr>
-          <p:cNvPr id="123" name="">
-            <a:extLst xmlns:a="http://schemas.openxmlformats.org/drawingml/2006/main">
-              <a:ext uri="{FF2B5EF4-FFF2-40B4-BE49-F238E27FC236}">
-                <a16:creationId xmlns:a16="http://schemas.microsoft.com/office/drawing/2014/main" id="{92C95A2C-C373-4A4C-870F-759D5F7C1756}"/>
-              </a:ext>
-            </a:extLst>
-          </p:cNvPr>
-          <p:cNvCxnSpPr>
-            <a:stCxn xmlns:a="http://schemas.openxmlformats.org/drawingml/2006/main" id="114" idx="1"/>
-            <a:endCxn xmlns:a="http://schemas.openxmlformats.org/drawingml/2006/main" id="118" idx="3"/>
-          </p:cNvCxnSpPr>
-          <p:nvPr/>
-        </p:nvCxnSpPr>
-        <p:spPr>
-          <a:xfrm xmlns:a="http://schemas.openxmlformats.org/drawingml/2006/main" flipH="1">
-            <a:off x="2867025" y="1762125"/>
-            <a:ext cx="428625" cy="1514475"/>
-          </a:xfrm>
-          <a:prstGeom xmlns:a="http://schemas.openxmlformats.org/drawingml/2006/main" prst="bentConnector3">
-            <a:avLst>
-              <a:gd name="adj1" fmla="val 50000"/>
-            </a:avLst>
-          </a:prstGeom>
-          <a:ln xmlns:a="http://schemas.openxmlformats.org/drawingml/2006/main" w="19050">
-            <a:solidFill>
-              <a:srgbClr val="567481"/>
-            </a:solidFill>
-            <a:prstDash val="solid"/>
-            <a:tailEnd type="triangle" w="med" len="med"/>
-          </a:ln>
-        </p:spPr>
-      </p:cxnSp>
-      <p:cxnSp>
-        <p:nvCxnSpPr>
-          <p:cNvPr id="122" name="">
-            <a:extLst xmlns:a="http://schemas.openxmlformats.org/drawingml/2006/main">
-              <a:ext uri="{FF2B5EF4-FFF2-40B4-BE49-F238E27FC236}">
-                <a16:creationId xmlns:a16="http://schemas.microsoft.com/office/drawing/2014/main" id="{E0AC763B-A649-4FB0-B12C-29F37315DB39}"/>
-              </a:ext>
-            </a:extLst>
-          </p:cNvPr>
-          <p:cNvCxnSpPr>
-            <a:stCxn xmlns:a="http://schemas.openxmlformats.org/drawingml/2006/main" id="113" idx="2"/>
-            <a:endCxn xmlns:a="http://schemas.openxmlformats.org/drawingml/2006/main" id="118" idx="0"/>
-          </p:cNvCxnSpPr>
-          <p:nvPr/>
-        </p:nvCxnSpPr>
-        <p:spPr>
-          <a:xfrm xmlns:a="http://schemas.openxmlformats.org/drawingml/2006/main">
-            <a:off x="1604963" y="2143125"/>
-            <a:ext cx="0" cy="752475"/>
-          </a:xfrm>
-          <a:prstGeom xmlns:a="http://schemas.openxmlformats.org/drawingml/2006/main" prst="straightConnector1">
-            <a:avLst/>
-          </a:prstGeom>
-          <a:ln xmlns:a="http://schemas.openxmlformats.org/drawingml/2006/main" w="19050">
-            <a:solidFill>
-              <a:srgbClr val="567481"/>
-            </a:solidFill>
-            <a:prstDash val="solid"/>
-            <a:tailEnd type="triangle" w="med" len="med"/>
-          </a:ln>
-        </p:spPr>
-      </p:cxnSp>
-      <p:cxnSp>
-        <p:nvCxnSpPr>
-          <p:cNvPr id="121" name="">
-            <a:extLst xmlns:a="http://schemas.openxmlformats.org/drawingml/2006/main">
-              <a:ext uri="{FF2B5EF4-FFF2-40B4-BE49-F238E27FC236}">
-                <a16:creationId xmlns:a16="http://schemas.microsoft.com/office/drawing/2014/main" id="{D6FDC837-2944-4556-886A-CF55D0FB9A3C}"/>
-              </a:ext>
-            </a:extLst>
-          </p:cNvPr>
-          <p:cNvCxnSpPr>
-            <a:stCxn xmlns:a="http://schemas.openxmlformats.org/drawingml/2006/main" id="114" idx="2"/>
-            <a:endCxn xmlns:a="http://schemas.openxmlformats.org/drawingml/2006/main" id="119" idx="0"/>
-          </p:cNvCxnSpPr>
-          <p:nvPr/>
-        </p:nvCxnSpPr>
-        <p:spPr>
-          <a:xfrm xmlns:a="http://schemas.openxmlformats.org/drawingml/2006/main">
-            <a:off x="4557713" y="2143125"/>
-            <a:ext cx="0" cy="752475"/>
-          </a:xfrm>
-          <a:prstGeom xmlns:a="http://schemas.openxmlformats.org/drawingml/2006/main" prst="straightConnector1">
-            <a:avLst/>
-          </a:prstGeom>
-          <a:ln xmlns:a="http://schemas.openxmlformats.org/drawingml/2006/main" w="19050">
-            <a:solidFill>
-              <a:srgbClr val="567481"/>
-            </a:solidFill>
-            <a:prstDash val="solid"/>
-            <a:tailEnd type="triangle" w="med" len="med"/>
-          </a:ln>
-        </p:spPr>
-      </p:cxnSp>
-      <p:pic>
-        <p:nvPicPr>
-          <p:cNvPr id="108" name="Google Shape;108;p20">
-            <a:extLst xmlns:a="http://schemas.openxmlformats.org/drawingml/2006/main">
-              <a:ext uri="{FF2B5EF4-FFF2-40B4-BE49-F238E27FC236}">
-                <a16:creationId xmlns:a16="http://schemas.microsoft.com/office/drawing/2014/main" id="{65D35562-4BBA-4056-8A7E-71F1F31C6F5E}"/>
-              </a:ext>
-            </a:extLst>
-          </p:cNvPr>
-          <p:cNvPicPr>
-            <a:picLocks xmlns:a="http://schemas.openxmlformats.org/drawingml/2006/main" noChangeAspect="1"/>
-          </p:cNvPicPr>
-          <p:nvPr/>
-        </p:nvPicPr>
-        <p:blipFill rotWithShape="1">
-          <a:blip xmlns:r="http://schemas.openxmlformats.org/officeDocument/2006/relationships" xmlns:a="http://schemas.openxmlformats.org/drawingml/2006/main" r:embed="R164f1759a5d54763">
-            <a:alphaModFix/>
-          </a:blip>
-          <a:srcRect xmlns:a="http://schemas.openxmlformats.org/drawingml/2006/main" l="0" t="0" r="0" b="98001"/>
-          <a:stretch xmlns:a="http://schemas.openxmlformats.org/drawingml/2006/main"/>
-        </p:blipFill>
-        <p:spPr>
-          <a:xfrm xmlns:a="http://schemas.openxmlformats.org/drawingml/2006/main">
-            <a:off x="0" y="5093562"/>
-            <a:ext cx="9144000" cy="54275"/>
-          </a:xfrm>
-          <a:prstGeom xmlns:a="http://schemas.openxmlformats.org/drawingml/2006/main" prst="rect">
-            <a:avLst/>
-          </a:prstGeom>
-          <a:ln xmlns:a="http://schemas.openxmlformats.org/drawingml/2006/main">
-            <a:noFill/>
-          </a:ln>
-        </p:spPr>
-      </p:pic>
-      <p:pic>
-        <p:nvPicPr>
-          <p:cNvPr id="109" name="Google Shape;109;p20">
-            <a:extLst xmlns:a="http://schemas.openxmlformats.org/drawingml/2006/main">
-              <a:ext uri="{FF2B5EF4-FFF2-40B4-BE49-F238E27FC236}">
-                <a16:creationId xmlns:a16="http://schemas.microsoft.com/office/drawing/2014/main" id="{B03932EA-EF4D-47EB-9379-3A4E081CEF99}"/>
-              </a:ext>
-            </a:extLst>
-          </p:cNvPr>
-          <p:cNvPicPr>
-            <a:picLocks xmlns:a="http://schemas.openxmlformats.org/drawingml/2006/main" noChangeAspect="1"/>
-          </p:cNvPicPr>
-          <p:nvPr/>
-        </p:nvPicPr>
-        <p:blipFill>
-          <a:blip xmlns:r="http://schemas.openxmlformats.org/officeDocument/2006/relationships" xmlns:a="http://schemas.openxmlformats.org/drawingml/2006/main" r:embed="Rce84b5cdb3b44a81">
-            <a:alphaModFix/>
-          </a:blip>
-          <a:stretch xmlns:a="http://schemas.openxmlformats.org/drawingml/2006/main">
-            <a:fillRect l="0" t="0" r="0" b="0"/>
-          </a:stretch>
-        </p:blipFill>
-        <p:spPr>
-          <a:xfrm xmlns:a="http://schemas.openxmlformats.org/drawingml/2006/main">
-            <a:off x="0" y="1"/>
-            <a:ext cx="9144000" cy="507359"/>
-          </a:xfrm>
-          <a:prstGeom xmlns:a="http://schemas.openxmlformats.org/drawingml/2006/main" prst="rect">
-            <a:avLst/>
-          </a:prstGeom>
-          <a:ln xmlns:a="http://schemas.openxmlformats.org/drawingml/2006/main">
-            <a:noFill/>
-          </a:ln>
-        </p:spPr>
-      </p:pic>
-      <p:sp>
-        <p:nvSpPr>
-          <p:cNvPr id="110" name="Google Shape;110;p20">
-            <a:extLst xmlns:a="http://schemas.openxmlformats.org/drawingml/2006/main">
-              <a:ext uri="{FF2B5EF4-FFF2-40B4-BE49-F238E27FC236}">
-                <a16:creationId xmlns:a16="http://schemas.microsoft.com/office/drawing/2014/main" id="{896743BD-AB24-4FB6-82C4-80FF7C04A51F}"/>
-              </a:ext>
-            </a:extLst>
-          </p:cNvPr>
-          <p:cNvSpPr>
-            <a:spLocks xmlns:a="http://schemas.openxmlformats.org/drawingml/2006/main" noGrp="1"/>
-          </p:cNvSpPr>
-          <p:nvPr/>
-        </p:nvSpPr>
-        <p:spPr>
-          <a:xfrm xmlns:a="http://schemas.openxmlformats.org/drawingml/2006/main">
-            <a:off x="0" y="5067300"/>
-            <a:ext cx="9144000" cy="76200"/>
-          </a:xfrm>
-          <a:prstGeom xmlns:a="http://schemas.openxmlformats.org/drawingml/2006/main" prst="rect">
-            <a:avLst/>
-          </a:prstGeom>
-          <a:solidFill xmlns:a="http://schemas.openxmlformats.org/drawingml/2006/main">
-            <a:schemeClr val="dk1"/>
-          </a:solidFill>
-          <a:ln xmlns:a="http://schemas.openxmlformats.org/drawingml/2006/main">
-            <a:noFill/>
-          </a:ln>
-        </p:spPr>
-        <p:txBody>
-          <a:bodyPr xmlns:a="http://schemas.openxmlformats.org/drawingml/2006/main" spcFirstLastPara="1" wrap="square" lIns="91425" tIns="91425" rIns="91425" bIns="91425" anchor="ctr">
-            <a:noAutofit/>
-          </a:bodyPr>
-          <a:lstStyle xmlns:a="http://schemas.openxmlformats.org/drawingml/2006/main"/>
-          <a:p xmlns:a="http://schemas.openxmlformats.org/drawingml/2006/main">
-            <a:pPr marL="0" lvl="0" indent="0" algn="ctr">
-              <a:spcBef>
-                <a:spcPts val="0"/>
-              </a:spcBef>
-              <a:spcAft>
-                <a:spcPts val="0"/>
-              </a:spcAft>
-              <a:buNone/>
-            </a:pPr>
-            <a:r>
-              <a:t/>
-            </a:r>
-            <a:endParaRPr/>
-          </a:p>
-        </p:txBody>
-      </p:sp>
-      <p:sp>
-        <p:nvSpPr>
-          <p:cNvPr id="111" name="Cloud architecture and trust boundaries">
-            <a:extLst xmlns:a="http://schemas.openxmlformats.org/drawingml/2006/main">
-              <a:ext uri="{FF2B5EF4-FFF2-40B4-BE49-F238E27FC236}">
-                <a16:creationId xmlns:a16="http://schemas.microsoft.com/office/drawing/2014/main" id="{DDE67BC4-4E6B-40F7-8769-155EE925E405}"/>
-              </a:ext>
-            </a:extLst>
-          </p:cNvPr>
-          <p:cNvSpPr>
-            <a:spLocks xmlns:a="http://schemas.openxmlformats.org/drawingml/2006/main" noGrp="1"/>
-          </p:cNvSpPr>
-          <p:nvPr/>
-        </p:nvSpPr>
-        <p:spPr>
-          <a:xfrm xmlns:a="http://schemas.openxmlformats.org/drawingml/2006/main">
-            <a:off x="266700" y="666750"/>
-            <a:ext cx="8610600" cy="409575"/>
-          </a:xfrm>
-          <a:prstGeom xmlns:a="http://schemas.openxmlformats.org/drawingml/2006/main" prst="rect">
-            <a:avLst/>
-          </a:prstGeom>
-          <a:noFill xmlns:a="http://schemas.openxmlformats.org/drawingml/2006/main"/>
-          <a:ln xmlns:a="http://schemas.openxmlformats.org/drawingml/2006/main" w="0">
-            <a:noFill/>
-          </a:ln>
-        </p:spPr>
-        <p:txBody>
-          <a:bodyPr xmlns:a="http://schemas.openxmlformats.org/drawingml/2006/main" lIns="0" tIns="0" rIns="0" bIns="0" anchor="t"/>
-          <a:lstStyle xmlns:a="http://schemas.openxmlformats.org/drawingml/2006/main">
-            <a:defPPr>
-              <a:defRPr sz="1875" b="1">
-                <a:solidFill>
-                  <a:srgbClr val="17212B"/>
-                </a:solidFill>
-                <a:latin typeface="Google Sans Flex Medium"/>
-                <a:ea typeface="Google Sans Flex Medium"/>
-                <a:cs typeface="Google Sans Flex Medium"/>
-              </a:defRPr>
-            </a:defPPr>
-          </a:lstStyle>
-          <a:p xmlns:a="http://schemas.openxmlformats.org/drawingml/2006/main">
-            <a:pPr>
-              <a:defRPr sz="1875" b="1">
-                <a:solidFill>
-                  <a:srgbClr val="17212B"/>
-                </a:solidFill>
-                <a:latin typeface="Google Sans Flex Medium"/>
-                <a:ea typeface="Google Sans Flex Medium"/>
-                <a:cs typeface="Google Sans Flex Medium"/>
-              </a:defRPr>
-            </a:pPr>
-            <a:r>
-              <a:rPr sz="1875" b="1">
-                <a:solidFill>
-                  <a:srgbClr val="17212B"/>
-                </a:solidFill>
-                <a:latin typeface="Google Sans Flex Medium"/>
-                <a:ea typeface="Google Sans Flex Medium"/>
-                <a:cs typeface="Google Sans Flex Medium"/>
-              </a:rPr>
-              <a:t>Cloud architecture and trust boundaries</a:t>
-            </a:r>
-          </a:p>
-        </p:txBody>
-      </p:sp>
-      <p:sp>
-        <p:nvSpPr>
-          <p:cNvPr id="112" name="OpsCrew  /  Cloud evidence review  /  7">
-            <a:extLst xmlns:a="http://schemas.openxmlformats.org/drawingml/2006/main">
-              <a:ext uri="{FF2B5EF4-FFF2-40B4-BE49-F238E27FC236}">
-                <a16:creationId xmlns:a16="http://schemas.microsoft.com/office/drawing/2014/main" id="{124E92ED-F163-4831-B0AE-7B892DB60ABF}"/>
-              </a:ext>
-            </a:extLst>
-          </p:cNvPr>
-          <p:cNvSpPr>
-            <a:spLocks xmlns:a="http://schemas.openxmlformats.org/drawingml/2006/main" noGrp="1"/>
-          </p:cNvSpPr>
-          <p:nvPr/>
-        </p:nvSpPr>
-        <p:spPr>
-          <a:xfrm xmlns:a="http://schemas.openxmlformats.org/drawingml/2006/main">
-            <a:off x="266700" y="4810125"/>
-            <a:ext cx="8572500" cy="190500"/>
-          </a:xfrm>
-          <a:prstGeom xmlns:a="http://schemas.openxmlformats.org/drawingml/2006/main" prst="rect">
-            <a:avLst/>
-          </a:prstGeom>
-          <a:noFill xmlns:a="http://schemas.openxmlformats.org/drawingml/2006/main"/>
-          <a:ln xmlns:a="http://schemas.openxmlformats.org/drawingml/2006/main" w="0">
-            <a:noFill/>
-          </a:ln>
-        </p:spPr>
-        <p:txBody>
-          <a:bodyPr xmlns:a="http://schemas.openxmlformats.org/drawingml/2006/main" lIns="0" tIns="0" rIns="0" bIns="0" anchor="t"/>
-          <a:lstStyle xmlns:a="http://schemas.openxmlformats.org/drawingml/2006/main">
-            <a:defPPr>
-              <a:defRPr sz="900" b="0">
-                <a:solidFill>
-                  <a:srgbClr val="59636E"/>
-                </a:solidFill>
-                <a:latin typeface="Google Sans Flex Medium"/>
-                <a:ea typeface="Google Sans Flex Medium"/>
-                <a:cs typeface="Google Sans Flex Medium"/>
-              </a:defRPr>
-            </a:defPPr>
-          </a:lstStyle>
-          <a:p xmlns:a="http://schemas.openxmlformats.org/drawingml/2006/main">
-            <a:pPr>
-              <a:defRPr sz="900" b="0">
-                <a:solidFill>
-                  <a:srgbClr val="59636E"/>
-                </a:solidFill>
-                <a:latin typeface="Google Sans Flex Medium"/>
-                <a:ea typeface="Google Sans Flex Medium"/>
-                <a:cs typeface="Google Sans Flex Medium"/>
-              </a:defRPr>
-            </a:pPr>
-            <a:r>
-              <a:rPr sz="900" b="0">
-                <a:solidFill>
-                  <a:srgbClr val="59636E"/>
-                </a:solidFill>
-                <a:latin typeface="Google Sans Flex Medium"/>
-                <a:ea typeface="Google Sans Flex Medium"/>
-                <a:cs typeface="Google Sans Flex Medium"/>
-              </a:rPr>
-              <a:t>OpsCrew  /  Cloud evidence review  /  7</a:t>
-            </a:r>
-          </a:p>
-        </p:txBody>
-      </p:sp>
-      <p:sp>
-        <p:nvSpPr>
-          <p:cNvPr id="113" name="Browser&#10;English React interface">
-            <a:extLst xmlns:a="http://schemas.openxmlformats.org/drawingml/2006/main">
-              <a:ext uri="{FF2B5EF4-FFF2-40B4-BE49-F238E27FC236}">
-                <a16:creationId xmlns:a16="http://schemas.microsoft.com/office/drawing/2014/main" id="{44D4E716-068D-47A0-841F-AAA0A12A3B01}"/>
-              </a:ext>
-            </a:extLst>
-          </p:cNvPr>
-          <p:cNvSpPr>
-            <a:spLocks xmlns:a="http://schemas.openxmlformats.org/drawingml/2006/main" noGrp="1"/>
-          </p:cNvSpPr>
-          <p:nvPr/>
-        </p:nvSpPr>
-        <p:spPr>
-          <a:xfrm xmlns:a="http://schemas.openxmlformats.org/drawingml/2006/main">
-            <a:off x="342900" y="1381125"/>
-            <a:ext cx="2524125" cy="762000"/>
-          </a:xfrm>
-          <a:prstGeom xmlns:a="http://schemas.openxmlformats.org/drawingml/2006/main" prst="rect">
-            <a:avLst/>
-          </a:prstGeom>
-          <a:solidFill xmlns:a="http://schemas.openxmlformats.org/drawingml/2006/main">
-            <a:srgbClr val="F1F6F8"/>
-          </a:solidFill>
-          <a:ln xmlns:a="http://schemas.openxmlformats.org/drawingml/2006/main" w="9525">
-            <a:solidFill>
-              <a:srgbClr val="B8CCD3"/>
-            </a:solidFill>
-          </a:ln>
-        </p:spPr>
-        <p:txBody>
-          <a:bodyPr xmlns:a="http://schemas.openxmlformats.org/drawingml/2006/main" lIns="114300" tIns="114300" rIns="114300" bIns="114300" anchor="ctr"/>
-          <a:lstStyle xmlns:a="http://schemas.openxmlformats.org/drawingml/2006/main">
-            <a:defPPr algn="ctr">
-              <a:defRPr sz="1575">
-                <a:solidFill>
-                  <a:srgbClr val="173B4C"/>
-                </a:solidFill>
-                <a:latin typeface="Google Sans Flex Medium"/>
-                <a:ea typeface="Google Sans Flex Medium"/>
-                <a:cs typeface="Google Sans Flex Medium"/>
-              </a:defRPr>
-            </a:defPPr>
-          </a:lstStyle>
-          <a:p xmlns:a="http://schemas.openxmlformats.org/drawingml/2006/main">
-            <a:pPr algn="ctr">
-              <a:defRPr sz="1575">
-                <a:solidFill>
-                  <a:srgbClr val="173B4C"/>
-                </a:solidFill>
-                <a:latin typeface="Google Sans Flex Medium"/>
-                <a:ea typeface="Google Sans Flex Medium"/>
-                <a:cs typeface="Google Sans Flex Medium"/>
-              </a:defRPr>
-            </a:pPr>
-            <a:r>
-              <a:rPr sz="1575">
-                <a:solidFill>
-                  <a:srgbClr val="173B4C"/>
-                </a:solidFill>
-                <a:latin typeface="Google Sans Flex Medium"/>
-                <a:ea typeface="Google Sans Flex Medium"/>
-                <a:cs typeface="Google Sans Flex Medium"/>
-              </a:rPr>
-              <a:t>Browser</a:t>
-            </a:r>
-          </a:p>
-          <a:p xmlns:a="http://schemas.openxmlformats.org/drawingml/2006/main">
-            <a:pPr algn="ctr">
-              <a:defRPr sz="1575">
-                <a:solidFill>
-                  <a:srgbClr val="173B4C"/>
-                </a:solidFill>
-                <a:latin typeface="Google Sans Flex Medium"/>
-                <a:ea typeface="Google Sans Flex Medium"/>
-                <a:cs typeface="Google Sans Flex Medium"/>
-              </a:defRPr>
-            </a:pPr>
-            <a:r>
-              <a:rPr sz="1575">
-                <a:solidFill>
-                  <a:srgbClr val="173B4C"/>
-                </a:solidFill>
-                <a:latin typeface="Google Sans Flex Medium"/>
-                <a:ea typeface="Google Sans Flex Medium"/>
-                <a:cs typeface="Google Sans Flex Medium"/>
-              </a:rPr>
-              <a:t>English React interface</a:t>
-            </a:r>
-          </a:p>
-        </p:txBody>
-      </p:sp>
-      <p:sp>
-        <p:nvSpPr>
-          <p:cNvPr id="114" name="Cloud Run&#10;Node API + validators">
-            <a:extLst xmlns:a="http://schemas.openxmlformats.org/drawingml/2006/main">
-              <a:ext uri="{FF2B5EF4-FFF2-40B4-BE49-F238E27FC236}">
-                <a16:creationId xmlns:a16="http://schemas.microsoft.com/office/drawing/2014/main" id="{DAF275CE-3BC4-43E2-A081-82395022C582}"/>
-              </a:ext>
-            </a:extLst>
-          </p:cNvPr>
-          <p:cNvSpPr>
-            <a:spLocks xmlns:a="http://schemas.openxmlformats.org/drawingml/2006/main" noGrp="1"/>
-          </p:cNvSpPr>
-          <p:nvPr/>
-        </p:nvSpPr>
-        <p:spPr>
-          <a:xfrm xmlns:a="http://schemas.openxmlformats.org/drawingml/2006/main">
-            <a:off x="3295650" y="1381125"/>
-            <a:ext cx="2524125" cy="762000"/>
-          </a:xfrm>
-          <a:prstGeom xmlns:a="http://schemas.openxmlformats.org/drawingml/2006/main" prst="rect">
-            <a:avLst/>
-          </a:prstGeom>
-          <a:solidFill xmlns:a="http://schemas.openxmlformats.org/drawingml/2006/main">
-            <a:srgbClr val="F1F6F8"/>
-          </a:solidFill>
-          <a:ln xmlns:a="http://schemas.openxmlformats.org/drawingml/2006/main" w="9525">
-            <a:solidFill>
-              <a:srgbClr val="B8CCD3"/>
-            </a:solidFill>
-          </a:ln>
-        </p:spPr>
-        <p:txBody>
-          <a:bodyPr xmlns:a="http://schemas.openxmlformats.org/drawingml/2006/main" lIns="114300" tIns="114300" rIns="114300" bIns="114300" anchor="ctr"/>
-          <a:lstStyle xmlns:a="http://schemas.openxmlformats.org/drawingml/2006/main">
-            <a:defPPr algn="ctr">
-              <a:defRPr sz="1575">
-                <a:solidFill>
-                  <a:srgbClr val="173B4C"/>
-                </a:solidFill>
-                <a:latin typeface="Google Sans Flex Medium"/>
-                <a:ea typeface="Google Sans Flex Medium"/>
-                <a:cs typeface="Google Sans Flex Medium"/>
-              </a:defRPr>
-            </a:defPPr>
-          </a:lstStyle>
-          <a:p xmlns:a="http://schemas.openxmlformats.org/drawingml/2006/main">
-            <a:pPr algn="ctr">
-              <a:defRPr sz="1575">
-                <a:solidFill>
-                  <a:srgbClr val="173B4C"/>
-                </a:solidFill>
-                <a:latin typeface="Google Sans Flex Medium"/>
-                <a:ea typeface="Google Sans Flex Medium"/>
-                <a:cs typeface="Google Sans Flex Medium"/>
-              </a:defRPr>
-            </a:pPr>
-            <a:r>
-              <a:rPr sz="1575">
-                <a:solidFill>
-                  <a:srgbClr val="173B4C"/>
-                </a:solidFill>
-                <a:latin typeface="Google Sans Flex Medium"/>
-                <a:ea typeface="Google Sans Flex Medium"/>
-                <a:cs typeface="Google Sans Flex Medium"/>
-              </a:rPr>
-              <a:t>Cloud Run</a:t>
-            </a:r>
-          </a:p>
-          <a:p xmlns:a="http://schemas.openxmlformats.org/drawingml/2006/main">
-            <a:pPr algn="ctr">
-              <a:defRPr sz="1575">
-                <a:solidFill>
-                  <a:srgbClr val="173B4C"/>
-                </a:solidFill>
-                <a:latin typeface="Google Sans Flex Medium"/>
-                <a:ea typeface="Google Sans Flex Medium"/>
-                <a:cs typeface="Google Sans Flex Medium"/>
-              </a:defRPr>
-            </a:pPr>
-            <a:r>
-              <a:rPr sz="1575">
-                <a:solidFill>
-                  <a:srgbClr val="173B4C"/>
-                </a:solidFill>
-                <a:latin typeface="Google Sans Flex Medium"/>
-                <a:ea typeface="Google Sans Flex Medium"/>
-                <a:cs typeface="Google Sans Flex Medium"/>
-              </a:rPr>
-              <a:t>Node API + validators</a:t>
-            </a:r>
-          </a:p>
-        </p:txBody>
-      </p:sp>
-      <p:sp>
-        <p:nvSpPr>
-          <p:cNvPr id="115" name="Gemini API&#10;Facts / plan / review">
-            <a:extLst xmlns:a="http://schemas.openxmlformats.org/drawingml/2006/main">
-              <a:ext uri="{FF2B5EF4-FFF2-40B4-BE49-F238E27FC236}">
-                <a16:creationId xmlns:a16="http://schemas.microsoft.com/office/drawing/2014/main" id="{9D48FE94-1994-4DA2-A228-4658AFF383CD}"/>
-              </a:ext>
-            </a:extLst>
-          </p:cNvPr>
-          <p:cNvSpPr>
-            <a:spLocks xmlns:a="http://schemas.openxmlformats.org/drawingml/2006/main" noGrp="1"/>
-          </p:cNvSpPr>
-          <p:nvPr/>
-        </p:nvSpPr>
-        <p:spPr>
-          <a:xfrm xmlns:a="http://schemas.openxmlformats.org/drawingml/2006/main">
-            <a:off x="6248400" y="1381125"/>
-            <a:ext cx="2524125" cy="762000"/>
-          </a:xfrm>
-          <a:prstGeom xmlns:a="http://schemas.openxmlformats.org/drawingml/2006/main" prst="rect">
-            <a:avLst/>
-          </a:prstGeom>
-          <a:solidFill xmlns:a="http://schemas.openxmlformats.org/drawingml/2006/main">
-            <a:srgbClr val="F1F6F8"/>
-          </a:solidFill>
-          <a:ln xmlns:a="http://schemas.openxmlformats.org/drawingml/2006/main" w="9525">
-            <a:solidFill>
-              <a:srgbClr val="B8CCD3"/>
-            </a:solidFill>
-          </a:ln>
-        </p:spPr>
-        <p:txBody>
-          <a:bodyPr xmlns:a="http://schemas.openxmlformats.org/drawingml/2006/main" lIns="114300" tIns="114300" rIns="114300" bIns="114300" anchor="ctr"/>
-          <a:lstStyle xmlns:a="http://schemas.openxmlformats.org/drawingml/2006/main">
-            <a:defPPr algn="ctr">
-              <a:defRPr sz="1575">
-                <a:solidFill>
-                  <a:srgbClr val="173B4C"/>
-                </a:solidFill>
-                <a:latin typeface="Google Sans Flex Medium"/>
-                <a:ea typeface="Google Sans Flex Medium"/>
-                <a:cs typeface="Google Sans Flex Medium"/>
-              </a:defRPr>
-            </a:defPPr>
-          </a:lstStyle>
-          <a:p xmlns:a="http://schemas.openxmlformats.org/drawingml/2006/main">
-            <a:pPr algn="ctr">
-              <a:defRPr sz="1575">
-                <a:solidFill>
-                  <a:srgbClr val="173B4C"/>
-                </a:solidFill>
-                <a:latin typeface="Google Sans Flex Medium"/>
-                <a:ea typeface="Google Sans Flex Medium"/>
-                <a:cs typeface="Google Sans Flex Medium"/>
-              </a:defRPr>
-            </a:pPr>
-            <a:r>
-              <a:rPr sz="1575">
-                <a:solidFill>
-                  <a:srgbClr val="173B4C"/>
-                </a:solidFill>
-                <a:latin typeface="Google Sans Flex Medium"/>
-                <a:ea typeface="Google Sans Flex Medium"/>
-                <a:cs typeface="Google Sans Flex Medium"/>
-              </a:rPr>
-              <a:t>Gemini API</a:t>
-            </a:r>
-          </a:p>
-          <a:p xmlns:a="http://schemas.openxmlformats.org/drawingml/2006/main">
-            <a:pPr algn="ctr">
-              <a:defRPr sz="1575">
-                <a:solidFill>
-                  <a:srgbClr val="173B4C"/>
-                </a:solidFill>
-                <a:latin typeface="Google Sans Flex Medium"/>
-                <a:ea typeface="Google Sans Flex Medium"/>
-                <a:cs typeface="Google Sans Flex Medium"/>
-              </a:defRPr>
-            </a:pPr>
-            <a:r>
-              <a:rPr sz="1575">
-                <a:solidFill>
-                  <a:srgbClr val="173B4C"/>
-                </a:solidFill>
-                <a:latin typeface="Google Sans Flex Medium"/>
-                <a:ea typeface="Google Sans Flex Medium"/>
-                <a:cs typeface="Google Sans Flex Medium"/>
-              </a:rPr>
-              <a:t>Facts / plan / review</a:t>
-            </a:r>
-          </a:p>
-        </p:txBody>
-      </p:sp>
-      <p:sp>
-        <p:nvSpPr>
-          <p:cNvPr id="116" name="">
-            <a:extLst xmlns:a="http://schemas.openxmlformats.org/drawingml/2006/main">
-              <a:ext uri="{FF2B5EF4-FFF2-40B4-BE49-F238E27FC236}">
-                <a16:creationId xmlns:a16="http://schemas.microsoft.com/office/drawing/2014/main" id="{D350A6B7-016F-4005-900E-1B3C3EAE6A1B}"/>
-              </a:ext>
-            </a:extLst>
-          </p:cNvPr>
-          <p:cNvSpPr>
-            <a:spLocks xmlns:a="http://schemas.openxmlformats.org/drawingml/2006/main" noGrp="1"/>
-          </p:cNvSpPr>
-          <p:nvPr/>
-        </p:nvSpPr>
-        <p:spPr>
-          <a:xfrm xmlns:a="http://schemas.openxmlformats.org/drawingml/2006/main">
-            <a:off x="2933700" y="1657350"/>
-            <a:ext cx="257175" cy="209550"/>
-          </a:xfrm>
-          <a:prstGeom xmlns:a="http://schemas.openxmlformats.org/drawingml/2006/main" prst="rightArrow">
-            <a:avLst/>
-          </a:prstGeom>
-          <a:solidFill xmlns:a="http://schemas.openxmlformats.org/drawingml/2006/main">
-            <a:srgbClr val="567481"/>
-          </a:solidFill>
-          <a:ln xmlns:a="http://schemas.openxmlformats.org/drawingml/2006/main" w="0">
-            <a:noFill/>
-          </a:ln>
-        </p:spPr>
-      </p:sp>
-      <p:sp>
-        <p:nvSpPr>
-          <p:cNvPr id="117" name="">
-            <a:extLst xmlns:a="http://schemas.openxmlformats.org/drawingml/2006/main">
-              <a:ext uri="{FF2B5EF4-FFF2-40B4-BE49-F238E27FC236}">
-                <a16:creationId xmlns:a16="http://schemas.microsoft.com/office/drawing/2014/main" id="{23CBDB75-8BA8-4C80-ACA7-3FA4BCAE3803}"/>
-              </a:ext>
-            </a:extLst>
-          </p:cNvPr>
-          <p:cNvSpPr>
-            <a:spLocks xmlns:a="http://schemas.openxmlformats.org/drawingml/2006/main" noGrp="1"/>
-          </p:cNvSpPr>
-          <p:nvPr/>
-        </p:nvSpPr>
-        <p:spPr>
-          <a:xfrm xmlns:a="http://schemas.openxmlformats.org/drawingml/2006/main">
-            <a:off x="5886450" y="1657350"/>
-            <a:ext cx="257175" cy="209550"/>
-          </a:xfrm>
-          <a:prstGeom xmlns:a="http://schemas.openxmlformats.org/drawingml/2006/main" prst="rightArrow">
-            <a:avLst/>
-          </a:prstGeom>
-          <a:solidFill xmlns:a="http://schemas.openxmlformats.org/drawingml/2006/main">
-            <a:srgbClr val="567481"/>
-          </a:solidFill>
-          <a:ln xmlns:a="http://schemas.openxmlformats.org/drawingml/2006/main" w="0">
-            <a:noFill/>
-          </a:ln>
-        </p:spPr>
-      </p:sp>
-      <p:sp>
-        <p:nvSpPr>
-          <p:cNvPr id="118" name="Firebase Auth&#10;Visitor identity">
-            <a:extLst xmlns:a="http://schemas.openxmlformats.org/drawingml/2006/main">
-              <a:ext uri="{FF2B5EF4-FFF2-40B4-BE49-F238E27FC236}">
-                <a16:creationId xmlns:a16="http://schemas.microsoft.com/office/drawing/2014/main" id="{250080ED-30C6-47A8-98F0-023D7E6A3F94}"/>
-              </a:ext>
-            </a:extLst>
-          </p:cNvPr>
-          <p:cNvSpPr>
-            <a:spLocks xmlns:a="http://schemas.openxmlformats.org/drawingml/2006/main" noGrp="1"/>
-          </p:cNvSpPr>
-          <p:nvPr/>
-        </p:nvSpPr>
-        <p:spPr>
-          <a:xfrm xmlns:a="http://schemas.openxmlformats.org/drawingml/2006/main">
-            <a:off x="342900" y="2895600"/>
-            <a:ext cx="2524125" cy="762000"/>
-          </a:xfrm>
-          <a:prstGeom xmlns:a="http://schemas.openxmlformats.org/drawingml/2006/main" prst="rect">
-            <a:avLst/>
-          </a:prstGeom>
-          <a:solidFill xmlns:a="http://schemas.openxmlformats.org/drawingml/2006/main">
-            <a:srgbClr val="F1F6F8"/>
-          </a:solidFill>
-          <a:ln xmlns:a="http://schemas.openxmlformats.org/drawingml/2006/main" w="9525">
-            <a:solidFill>
-              <a:srgbClr val="B8CCD3"/>
-            </a:solidFill>
-          </a:ln>
-        </p:spPr>
-        <p:txBody>
-          <a:bodyPr xmlns:a="http://schemas.openxmlformats.org/drawingml/2006/main" lIns="114300" tIns="114300" rIns="114300" bIns="114300" anchor="ctr"/>
-          <a:lstStyle xmlns:a="http://schemas.openxmlformats.org/drawingml/2006/main">
-            <a:defPPr algn="ctr">
-              <a:defRPr sz="1575">
-                <a:solidFill>
-                  <a:srgbClr val="173B4C"/>
-                </a:solidFill>
-                <a:latin typeface="Google Sans Flex Medium"/>
-                <a:ea typeface="Google Sans Flex Medium"/>
-                <a:cs typeface="Google Sans Flex Medium"/>
-              </a:defRPr>
-            </a:defPPr>
-          </a:lstStyle>
-          <a:p xmlns:a="http://schemas.openxmlformats.org/drawingml/2006/main">
-            <a:pPr algn="ctr">
-              <a:defRPr sz="1575">
-                <a:solidFill>
-                  <a:srgbClr val="173B4C"/>
-                </a:solidFill>
-                <a:latin typeface="Google Sans Flex Medium"/>
-                <a:ea typeface="Google Sans Flex Medium"/>
-                <a:cs typeface="Google Sans Flex Medium"/>
-              </a:defRPr>
-            </a:pPr>
-            <a:r>
-              <a:rPr sz="1575">
-                <a:solidFill>
-                  <a:srgbClr val="173B4C"/>
-                </a:solidFill>
-                <a:latin typeface="Google Sans Flex Medium"/>
-                <a:ea typeface="Google Sans Flex Medium"/>
-                <a:cs typeface="Google Sans Flex Medium"/>
-              </a:rPr>
-              <a:t>Firebase Auth</a:t>
-            </a:r>
-          </a:p>
-          <a:p xmlns:a="http://schemas.openxmlformats.org/drawingml/2006/main">
-            <a:pPr algn="ctr">
-              <a:defRPr sz="1575">
-                <a:solidFill>
-                  <a:srgbClr val="173B4C"/>
-                </a:solidFill>
-                <a:latin typeface="Google Sans Flex Medium"/>
-                <a:ea typeface="Google Sans Flex Medium"/>
-                <a:cs typeface="Google Sans Flex Medium"/>
-              </a:defRPr>
-            </a:pPr>
-            <a:r>
-              <a:rPr sz="1575">
-                <a:solidFill>
-                  <a:srgbClr val="173B4C"/>
-                </a:solidFill>
-                <a:latin typeface="Google Sans Flex Medium"/>
-                <a:ea typeface="Google Sans Flex Medium"/>
-                <a:cs typeface="Google Sans Flex Medium"/>
-              </a:rPr>
-              <a:t>Visitor identity</a:t>
-            </a:r>
-          </a:p>
-        </p:txBody>
-      </p:sp>
-      <p:sp>
-        <p:nvSpPr>
-          <p:cNvPr id="119" name="Firestore&#10;Plans / cases / quotas">
-            <a:extLst xmlns:a="http://schemas.openxmlformats.org/drawingml/2006/main">
-              <a:ext uri="{FF2B5EF4-FFF2-40B4-BE49-F238E27FC236}">
-                <a16:creationId xmlns:a16="http://schemas.microsoft.com/office/drawing/2014/main" id="{0B36E20F-2D2D-4F3F-9817-536CF79B64C3}"/>
-              </a:ext>
-            </a:extLst>
-          </p:cNvPr>
-          <p:cNvSpPr>
-            <a:spLocks xmlns:a="http://schemas.openxmlformats.org/drawingml/2006/main" noGrp="1"/>
-          </p:cNvSpPr>
-          <p:nvPr/>
-        </p:nvSpPr>
-        <p:spPr>
-          <a:xfrm xmlns:a="http://schemas.openxmlformats.org/drawingml/2006/main">
-            <a:off x="3295650" y="2895600"/>
-            <a:ext cx="2524125" cy="762000"/>
-          </a:xfrm>
-          <a:prstGeom xmlns:a="http://schemas.openxmlformats.org/drawingml/2006/main" prst="rect">
-            <a:avLst/>
-          </a:prstGeom>
-          <a:solidFill xmlns:a="http://schemas.openxmlformats.org/drawingml/2006/main">
-            <a:srgbClr val="F1F6F8"/>
-          </a:solidFill>
-          <a:ln xmlns:a="http://schemas.openxmlformats.org/drawingml/2006/main" w="9525">
-            <a:solidFill>
-              <a:srgbClr val="B8CCD3"/>
-            </a:solidFill>
-          </a:ln>
-        </p:spPr>
-        <p:txBody>
-          <a:bodyPr xmlns:a="http://schemas.openxmlformats.org/drawingml/2006/main" lIns="114300" tIns="114300" rIns="114300" bIns="114300" anchor="ctr"/>
-          <a:lstStyle xmlns:a="http://schemas.openxmlformats.org/drawingml/2006/main">
-            <a:defPPr algn="ctr">
-              <a:defRPr sz="1575">
-                <a:solidFill>
-                  <a:srgbClr val="173B4C"/>
-                </a:solidFill>
-                <a:latin typeface="Google Sans Flex Medium"/>
-                <a:ea typeface="Google Sans Flex Medium"/>
-                <a:cs typeface="Google Sans Flex Medium"/>
-              </a:defRPr>
-            </a:defPPr>
-          </a:lstStyle>
-          <a:p xmlns:a="http://schemas.openxmlformats.org/drawingml/2006/main">
-            <a:pPr algn="ctr">
-              <a:defRPr sz="1575">
-                <a:solidFill>
-                  <a:srgbClr val="173B4C"/>
-                </a:solidFill>
-                <a:latin typeface="Google Sans Flex Medium"/>
-                <a:ea typeface="Google Sans Flex Medium"/>
-                <a:cs typeface="Google Sans Flex Medium"/>
-              </a:defRPr>
-            </a:pPr>
-            <a:r>
-              <a:rPr sz="1575">
-                <a:solidFill>
-                  <a:srgbClr val="173B4C"/>
-                </a:solidFill>
-                <a:latin typeface="Google Sans Flex Medium"/>
-                <a:ea typeface="Google Sans Flex Medium"/>
-                <a:cs typeface="Google Sans Flex Medium"/>
-              </a:rPr>
-              <a:t>Firestore</a:t>
-            </a:r>
-          </a:p>
-          <a:p xmlns:a="http://schemas.openxmlformats.org/drawingml/2006/main">
-            <a:pPr algn="ctr">
-              <a:defRPr sz="1575">
-                <a:solidFill>
-                  <a:srgbClr val="173B4C"/>
-                </a:solidFill>
-                <a:latin typeface="Google Sans Flex Medium"/>
-                <a:ea typeface="Google Sans Flex Medium"/>
-                <a:cs typeface="Google Sans Flex Medium"/>
-              </a:defRPr>
-            </a:pPr>
-            <a:r>
-              <a:rPr sz="1575">
-                <a:solidFill>
-                  <a:srgbClr val="173B4C"/>
-                </a:solidFill>
-                <a:latin typeface="Google Sans Flex Medium"/>
-                <a:ea typeface="Google Sans Flex Medium"/>
-                <a:cs typeface="Google Sans Flex Medium"/>
-              </a:rPr>
-              <a:t>Plans / cases / quotas</a:t>
-            </a:r>
-          </a:p>
-        </p:txBody>
-      </p:sp>
-      <p:sp>
-        <p:nvSpPr>
-          <p:cNvPr id="120" name="Secret Manager&#10;Server credential only">
-            <a:extLst xmlns:a="http://schemas.openxmlformats.org/drawingml/2006/main">
-              <a:ext uri="{FF2B5EF4-FFF2-40B4-BE49-F238E27FC236}">
-                <a16:creationId xmlns:a16="http://schemas.microsoft.com/office/drawing/2014/main" id="{4551812B-D8A4-435A-9256-4CC28C6E2A37}"/>
-              </a:ext>
-            </a:extLst>
-          </p:cNvPr>
-          <p:cNvSpPr>
-            <a:spLocks xmlns:a="http://schemas.openxmlformats.org/drawingml/2006/main" noGrp="1"/>
-          </p:cNvSpPr>
-          <p:nvPr/>
-        </p:nvSpPr>
-        <p:spPr>
-          <a:xfrm xmlns:a="http://schemas.openxmlformats.org/drawingml/2006/main">
-            <a:off x="6248400" y="2895600"/>
-            <a:ext cx="2524125" cy="762000"/>
-          </a:xfrm>
-          <a:prstGeom xmlns:a="http://schemas.openxmlformats.org/drawingml/2006/main" prst="rect">
-            <a:avLst/>
-          </a:prstGeom>
-          <a:solidFill xmlns:a="http://schemas.openxmlformats.org/drawingml/2006/main">
-            <a:srgbClr val="F1F6F8"/>
-          </a:solidFill>
-          <a:ln xmlns:a="http://schemas.openxmlformats.org/drawingml/2006/main" w="9525">
-            <a:solidFill>
-              <a:srgbClr val="B8CCD3"/>
-            </a:solidFill>
-          </a:ln>
-        </p:spPr>
-        <p:txBody>
-          <a:bodyPr xmlns:a="http://schemas.openxmlformats.org/drawingml/2006/main" lIns="114300" tIns="114300" rIns="114300" bIns="114300" anchor="ctr"/>
-          <a:lstStyle xmlns:a="http://schemas.openxmlformats.org/drawingml/2006/main">
-            <a:defPPr algn="ctr">
-              <a:defRPr sz="1575">
-                <a:solidFill>
-                  <a:srgbClr val="173B4C"/>
-                </a:solidFill>
-                <a:latin typeface="Google Sans Flex Medium"/>
-                <a:ea typeface="Google Sans Flex Medium"/>
-                <a:cs typeface="Google Sans Flex Medium"/>
-              </a:defRPr>
-            </a:defPPr>
-          </a:lstStyle>
-          <a:p xmlns:a="http://schemas.openxmlformats.org/drawingml/2006/main">
-            <a:pPr algn="ctr">
-              <a:defRPr sz="1575">
-                <a:solidFill>
-                  <a:srgbClr val="173B4C"/>
-                </a:solidFill>
-                <a:latin typeface="Google Sans Flex Medium"/>
-                <a:ea typeface="Google Sans Flex Medium"/>
-                <a:cs typeface="Google Sans Flex Medium"/>
-              </a:defRPr>
-            </a:pPr>
-            <a:r>
-              <a:rPr sz="1575">
-                <a:solidFill>
-                  <a:srgbClr val="173B4C"/>
-                </a:solidFill>
-                <a:latin typeface="Google Sans Flex Medium"/>
-                <a:ea typeface="Google Sans Flex Medium"/>
-                <a:cs typeface="Google Sans Flex Medium"/>
-              </a:rPr>
-              <a:t>Secret Manager</a:t>
-            </a:r>
-          </a:p>
-          <a:p xmlns:a="http://schemas.openxmlformats.org/drawingml/2006/main">
-            <a:pPr algn="ctr">
-              <a:defRPr sz="1575">
-                <a:solidFill>
-                  <a:srgbClr val="173B4C"/>
-                </a:solidFill>
-                <a:latin typeface="Google Sans Flex Medium"/>
-                <a:ea typeface="Google Sans Flex Medium"/>
-                <a:cs typeface="Google Sans Flex Medium"/>
-              </a:defRPr>
-            </a:pPr>
-            <a:r>
-              <a:rPr sz="1575">
-                <a:solidFill>
-                  <a:srgbClr val="173B4C"/>
-                </a:solidFill>
-                <a:latin typeface="Google Sans Flex Medium"/>
-                <a:ea typeface="Google Sans Flex Medium"/>
-                <a:cs typeface="Google Sans Flex Medium"/>
-              </a:rPr>
-              <a:t>Server credential only</a:t>
-            </a:r>
-          </a:p>
-        </p:txBody>
-      </p:sp>
-      <p:sp>
-        <p:nvSpPr>
-          <p:cNvPr id="125" name="Recorded cloud APIs verify owner access, confirmat">
-            <a:extLst xmlns:a="http://schemas.openxmlformats.org/drawingml/2006/main">
-              <a:ext uri="{FF2B5EF4-FFF2-40B4-BE49-F238E27FC236}">
-                <a16:creationId xmlns:a16="http://schemas.microsoft.com/office/drawing/2014/main" id="{2E91F10B-C9CA-4580-AAD4-F657791F2B0C}"/>
-              </a:ext>
-            </a:extLst>
-          </p:cNvPr>
-          <p:cNvSpPr>
-            <a:spLocks xmlns:a="http://schemas.openxmlformats.org/drawingml/2006/main" noGrp="1"/>
-          </p:cNvSpPr>
-          <p:nvPr/>
-        </p:nvSpPr>
-        <p:spPr>
-          <a:xfrm xmlns:a="http://schemas.openxmlformats.org/drawingml/2006/main">
-            <a:off x="342900" y="4057650"/>
-            <a:ext cx="8429625" cy="685800"/>
-          </a:xfrm>
-          <a:prstGeom xmlns:a="http://schemas.openxmlformats.org/drawingml/2006/main" prst="rect">
-            <a:avLst/>
-          </a:prstGeom>
-          <a:noFill xmlns:a="http://schemas.openxmlformats.org/drawingml/2006/main"/>
-          <a:ln xmlns:a="http://schemas.openxmlformats.org/drawingml/2006/main" w="0">
-            <a:noFill/>
-          </a:ln>
-        </p:spPr>
-        <p:txBody>
-          <a:bodyPr xmlns:a="http://schemas.openxmlformats.org/drawingml/2006/main" lIns="0" tIns="0" rIns="0" bIns="0" anchor="t"/>
-          <a:lstStyle xmlns:a="http://schemas.openxmlformats.org/drawingml/2006/main">
-            <a:defPPr>
-              <a:defRPr sz="1500" b="0">
-                <a:solidFill>
-                  <a:srgbClr val="17212B"/>
-                </a:solidFill>
-                <a:latin typeface="Google Sans Flex Medium"/>
-                <a:ea typeface="Google Sans Flex Medium"/>
-                <a:cs typeface="Google Sans Flex Medium"/>
-              </a:defRPr>
-            </a:defPPr>
-          </a:lstStyle>
-          <a:p xmlns:a="http://schemas.openxmlformats.org/drawingml/2006/main">
-            <a:pPr>
-              <a:defRPr sz="1500" b="0">
-                <a:solidFill>
-                  <a:srgbClr val="17212B"/>
-                </a:solidFill>
-                <a:latin typeface="Google Sans Flex Medium"/>
-                <a:ea typeface="Google Sans Flex Medium"/>
-                <a:cs typeface="Google Sans Flex Medium"/>
-              </a:defRPr>
-            </a:pPr>
-            <a:r>
-              <a:rPr sz="1500" b="0">
-                <a:solidFill>
-                  <a:srgbClr val="17212B"/>
-                </a:solidFill>
-                <a:latin typeface="Google Sans Flex Medium"/>
-                <a:ea typeface="Google Sans Flex Medium"/>
-                <a:cs typeface="Google Sans Flex Medium"/>
-              </a:rPr>
-              <a:t>Recorded cloud APIs verify owner access, confirmation and saved-case readback. Direct visitor Firestore access is denied. Source-to-image identity and complete resource controls await verification.</a:t>
-            </a:r>
-          </a:p>
-        </p:txBody>
-      </p:sp>
     </p:spTree>
     <p:extLst>
       <p:ext uri="{BB962C8B-B14F-4D97-AF65-F5344CB8AC3E}">

</xml_diff>